<commit_message>
feat: reprocessa slides da missa Cinzas (71 slides)
</commit_message>
<xml_diff>
--- a/missas/Quaresma/Cinzas.pptx
+++ b/missas/Quaresma/Cinzas.pptx
@@ -61,6 +61,21 @@
     <p:sldId id="309" r:id="rId60"/>
     <p:sldId id="310" r:id="rId61"/>
     <p:sldId id="311" r:id="rId62"/>
+    <p:sldId id="312" r:id="rId63"/>
+    <p:sldId id="313" r:id="rId64"/>
+    <p:sldId id="314" r:id="rId65"/>
+    <p:sldId id="315" r:id="rId66"/>
+    <p:sldId id="316" r:id="rId67"/>
+    <p:sldId id="317" r:id="rId68"/>
+    <p:sldId id="318" r:id="rId69"/>
+    <p:sldId id="319" r:id="rId70"/>
+    <p:sldId id="320" r:id="rId71"/>
+    <p:sldId id="321" r:id="rId72"/>
+    <p:sldId id="322" r:id="rId73"/>
+    <p:sldId id="323" r:id="rId74"/>
+    <p:sldId id="324" r:id="rId75"/>
+    <p:sldId id="325" r:id="rId76"/>
+    <p:sldId id="326" r:id="rId77"/>
   </p:sldIdLst>
   <p:sldSz cx="12191695" cy="6858000" type="screen4x3"/>
   <p:notesSz cx="6858000" cy="9144000"/>
@@ -3236,8 +3251,7 @@
                   <a:srgbClr val="1A1A1A"/>
                 </a:solidFill>
               </a:rPr>
-              <a:t>Glória e louvor a vós, ó Cristo…
-Glória e louvor a vós, ó Cristo…</a:t>
+              <a:t>Miserere mei, Domine. Miserere mei, Domine.</a:t>
             </a:r>
           </a:p>
         </p:txBody>
@@ -3321,7 +3335,7 @@
                   <a:srgbClr val="1A1A1A"/>
                 </a:solidFill>
               </a:rPr>
-              <a:t>Cinzas</a:t>
+              <a:t>Aleluia</a:t>
             </a:r>
           </a:p>
         </p:txBody>
@@ -3379,10 +3393,8 @@
                   <a:srgbClr val="1A1A1A"/>
                 </a:solidFill>
               </a:rPr>
-              <a:t>Recorda-te de mim, ó Senhor
-Recorda-te de mim no teu Reino,
-no seu reino de paz infinita,
-recorda-te Jesus de mim…</a:t>
+              <a:t>Glória e louvor a vós, ó Cristo…
+Glória e louvor a vós, ó Cristo…</a:t>
             </a:r>
           </a:p>
         </p:txBody>
@@ -3401,7 +3413,7 @@
     <p:bg>
       <p:bgPr>
         <a:solidFill>
-          <a:srgbClr val="FAF9F7"/>
+          <a:srgbClr val="000000"/>
         </a:solidFill>
         <a:effectLst/>
       </p:bgPr>
@@ -3413,38 +3425,6 @@
         <p:nvPr/>
       </p:nvGrpSpPr>
       <p:grpSpPr/>
-      <p:sp>
-        <p:nvSpPr>
-          <p:cNvPr id="2" name="TextBox 1"/>
-          <p:cNvSpPr txBox="1"/>
-          <p:nvPr/>
-        </p:nvSpPr>
-        <p:spPr>
-          <a:xfrm>
-            <a:off x="731520" y="731520"/>
-            <a:ext cx="10728655" cy="5394960"/>
-          </a:xfrm>
-          <a:prstGeom prst="rect">
-            <a:avLst/>
-          </a:prstGeom>
-          <a:noFill/>
-        </p:spPr>
-        <p:txBody>
-          <a:bodyPr wrap="square" anchor="ctr"/>
-          <a:lstStyle/>
-          <a:p>
-            <a:pPr algn="ctr"/>
-            <a:r>
-              <a:rPr sz="3200" b="0" i="0">
-                <a:solidFill>
-                  <a:srgbClr val="444444"/>
-                </a:solidFill>
-              </a:rPr>
-              <a:t>1. Em verdade eu digo…hoje estará comigoporque vim buscar o que estavao que estava perdido.2. É alegria no meu reinofestejar junto as minhasjunto as minhas ovelhas perdidasque foram encontradas.3. Feliz o que confiano amor do Senhorporque é eterno e grandea sua misericórdia...</a:t>
-            </a:r>
-          </a:p>
-        </p:txBody>
-      </p:sp>
     </p:spTree>
   </p:cSld>
   <p:clrMapOvr>
@@ -3479,6 +3459,64 @@
         </p:nvSpPr>
         <p:spPr>
           <a:xfrm>
+            <a:off x="731520" y="2057400"/>
+            <a:ext cx="10728655" cy="2400300"/>
+          </a:xfrm>
+          <a:prstGeom prst="rect">
+            <a:avLst/>
+          </a:prstGeom>
+          <a:noFill/>
+        </p:spPr>
+        <p:txBody>
+          <a:bodyPr wrap="square" anchor="ctr"/>
+          <a:lstStyle/>
+          <a:p>
+            <a:pPr algn="ctr"/>
+            <a:r>
+              <a:rPr sz="5200" b="1">
+                <a:solidFill>
+                  <a:srgbClr val="1A1A1A"/>
+                </a:solidFill>
+              </a:rPr>
+              <a:t>Cinzas</a:t>
+            </a:r>
+          </a:p>
+        </p:txBody>
+      </p:sp>
+    </p:spTree>
+  </p:cSld>
+  <p:clrMapOvr>
+    <a:masterClrMapping/>
+  </p:clrMapOvr>
+</p:sld>
+</file>
+
+<file path=ppt/slides/slide16.xml><?xml version="1.0" encoding="utf-8"?>
+<p:sld xmlns:a="http://schemas.openxmlformats.org/drawingml/2006/main" xmlns:p="http://schemas.openxmlformats.org/presentationml/2006/main" xmlns:r="http://schemas.openxmlformats.org/officeDocument/2006/relationships">
+  <p:cSld>
+    <p:bg>
+      <p:bgPr>
+        <a:solidFill>
+          <a:srgbClr val="FAF9F7"/>
+        </a:solidFill>
+        <a:effectLst/>
+      </p:bgPr>
+    </p:bg>
+    <p:spTree>
+      <p:nvGrpSpPr>
+        <p:cNvPr id="1" name=""/>
+        <p:cNvGrpSpPr/>
+        <p:nvPr/>
+      </p:nvGrpSpPr>
+      <p:grpSpPr/>
+      <p:sp>
+        <p:nvSpPr>
+          <p:cNvPr id="2" name="TextBox 1"/>
+          <p:cNvSpPr txBox="1"/>
+          <p:nvPr/>
+        </p:nvSpPr>
+        <p:spPr>
+          <a:xfrm>
             <a:off x="731520" y="731520"/>
             <a:ext cx="10728655" cy="5394960"/>
           </a:xfrm>
@@ -3514,32 +3552,6 @@
 </p:sld>
 </file>
 
-<file path=ppt/slides/slide16.xml><?xml version="1.0" encoding="utf-8"?>
-<p:sld xmlns:a="http://schemas.openxmlformats.org/drawingml/2006/main" xmlns:p="http://schemas.openxmlformats.org/presentationml/2006/main" xmlns:r="http://schemas.openxmlformats.org/officeDocument/2006/relationships">
-  <p:cSld>
-    <p:bg>
-      <p:bgPr>
-        <a:solidFill>
-          <a:srgbClr val="000000"/>
-        </a:solidFill>
-        <a:effectLst/>
-      </p:bgPr>
-    </p:bg>
-    <p:spTree>
-      <p:nvGrpSpPr>
-        <p:cNvPr id="1" name=""/>
-        <p:cNvGrpSpPr/>
-        <p:nvPr/>
-      </p:nvGrpSpPr>
-      <p:grpSpPr/>
-    </p:spTree>
-  </p:cSld>
-  <p:clrMapOvr>
-    <a:masterClrMapping/>
-  </p:clrMapOvr>
-</p:sld>
-</file>
-
 <file path=ppt/slides/slide17.xml><?xml version="1.0" encoding="utf-8"?>
 <p:sld xmlns:a="http://schemas.openxmlformats.org/drawingml/2006/main" xmlns:p="http://schemas.openxmlformats.org/presentationml/2006/main" xmlns:r="http://schemas.openxmlformats.org/officeDocument/2006/relationships">
   <p:cSld>
@@ -3566,8 +3578,8 @@
         </p:nvSpPr>
         <p:spPr>
           <a:xfrm>
-            <a:off x="731520" y="2057400"/>
-            <a:ext cx="10728655" cy="2400300"/>
+            <a:off x="731520" y="731520"/>
+            <a:ext cx="10728655" cy="5394960"/>
           </a:xfrm>
           <a:prstGeom prst="rect">
             <a:avLst/>
@@ -3580,12 +3592,12 @@
           <a:p>
             <a:pPr algn="ctr"/>
             <a:r>
-              <a:rPr sz="5200" b="1">
-                <a:solidFill>
-                  <a:srgbClr val="1A1A1A"/>
+              <a:rPr sz="3200" b="0" i="0">
+                <a:solidFill>
+                  <a:srgbClr val="444444"/>
                 </a:solidFill>
               </a:rPr>
-              <a:t>Cinzas</a:t>
+              <a:t>1. Em verdade eu digo…hoje estará comigoporque vim buscar o que estavao que estava perdido.</a:t>
             </a:r>
           </a:p>
         </p:txBody>
@@ -3643,7 +3655,10 @@
                   <a:srgbClr val="1A1A1A"/>
                 </a:solidFill>
               </a:rPr>
-              <a:t>Nos rios da Babilônia estamos chorando ao recordar de Sião, ao recordar de Sião.</a:t>
+              <a:t>Recorda-te de mim, ó Senhor
+Recorda-te de mim no teu Reino,
+no seu reino de paz infinita,
+recorda-te Jesus de mim…</a:t>
             </a:r>
           </a:p>
         </p:txBody>
@@ -3701,7 +3716,7 @@
                   <a:srgbClr val="444444"/>
                 </a:solidFill>
               </a:rPr>
-              <a:t>1. Ao sair daquela terra, ao sair penduramos nossas cítaras. Lá nos pediram canções aqueles que nos deportaram, canções de alegria nos exigiram. Cantai o canto de Sião... Como cantarei o canto do Senhor em terra estrangeira?</a:t>
+              <a:t>2. É alegria no meu reinofestejar junto as minhasjunto as minhas ovelhas perdidasque foram encontradas.</a:t>
             </a:r>
           </a:p>
         </p:txBody>
@@ -3785,7 +3800,10 @@
                   <a:srgbClr val="1A1A1A"/>
                 </a:solidFill>
               </a:rPr>
-              <a:t>Nos rios da Babilônia estamos chorando ao recordar de Sião, ao recordar de Sião.</a:t>
+              <a:t>Recorda-te de mim, ó Senhor
+Recorda-te de mim no teu Reino,
+no seu reino de paz infinita,
+recorda-te Jesus de mim…</a:t>
             </a:r>
           </a:p>
         </p:txBody>
@@ -3843,7 +3861,7 @@
                   <a:srgbClr val="444444"/>
                 </a:solidFill>
               </a:rPr>
-              <a:t>2. Se esquecer minha terra, Jerusalém, cidade santa! Se te esqueço Jerusalém, se paralise minha destra, minha língua se ate ao céu da boca, se a tua memória eu perder... se não colocá-la, Jerusalém, acima de toda alegria.</a:t>
+              <a:t>3. Feliz o que confiano amor do Senhorporque é eterno e grandea sua misericórdia...</a:t>
             </a:r>
           </a:p>
         </p:txBody>
@@ -3901,7 +3919,10 @@
                   <a:srgbClr val="1A1A1A"/>
                 </a:solidFill>
               </a:rPr>
-              <a:t>Nos rios da Babilônia estamos chorando ao recordar de Sião, ao recordar de Sião.</a:t>
+              <a:t>Recorda-te de mim, ó Senhor
+Recorda-te de mim no teu Reino,
+no seu reino de paz infinita,
+recorda-te Jesus de mim…</a:t>
             </a:r>
           </a:p>
         </p:txBody>
@@ -3985,7 +4006,7 @@
                   <a:srgbClr val="1A1A1A"/>
                 </a:solidFill>
               </a:rPr>
-              <a:t>Ofertório</a:t>
+              <a:t>Cinzas</a:t>
             </a:r>
           </a:p>
         </p:txBody>
@@ -4043,7 +4064,7 @@
                   <a:srgbClr val="1A1A1A"/>
                 </a:solidFill>
               </a:rPr>
-              <a:t>Pai, eu pequei contra o céu e contra ti, não sou digno de ser seu filho. Pai, piedade, piedade de mim. Pai, piedade, piedade de mim.</a:t>
+              <a:t>Nos rios da Babilônia estamos chorando ao recordar de Sião, ao recordar de Sião.</a:t>
             </a:r>
           </a:p>
         </p:txBody>
@@ -4101,7 +4122,7 @@
                   <a:srgbClr val="444444"/>
                 </a:solidFill>
               </a:rPr>
-              <a:t>1. Seu pai o viu quando ainda estava longe, ao vê-lo seu coração tremeu, então correu ao seu encontro, jogou-se em seu colo e o abraçou.2. O pai disse ao servo: tragam-me depressa, tragam aqui a veste mais bela, coloquem no dedo um anel, tragam calçados para ele.3. Preparai logo um bezerro grande, vamos comer e fazer uma festa, meu filho que estava morto agora vive, estava perdido e está aqui.</a:t>
+              <a:t>1. Ao sair daquela terra, ao sair penduramos nossas cítaras. Lá nos pediram canções aqueles que nos deportaram, canções de alegria nos exigiram. Cantai o canto de Sião... Como cantarei o canto do Senhor em terra estrangeira?</a:t>
             </a:r>
           </a:p>
         </p:txBody>
@@ -4159,7 +4180,7 @@
                   <a:srgbClr val="1A1A1A"/>
                 </a:solidFill>
               </a:rPr>
-              <a:t>Pai, eu pequei contra o céu e contra ti, não sou digno de ser seu filho. Pai, piedade, piedade de mim. Pai, piedade, piedade de mim.</a:t>
+              <a:t>Nos rios da Babilônia estamos chorando ao recordar de Sião, ao recordar de Sião.</a:t>
             </a:r>
           </a:p>
         </p:txBody>
@@ -4178,7 +4199,7 @@
     <p:bg>
       <p:bgPr>
         <a:solidFill>
-          <a:srgbClr val="000000"/>
+          <a:srgbClr val="FAF9F7"/>
         </a:solidFill>
         <a:effectLst/>
       </p:bgPr>
@@ -4190,6 +4211,38 @@
         <p:nvPr/>
       </p:nvGrpSpPr>
       <p:grpSpPr/>
+      <p:sp>
+        <p:nvSpPr>
+          <p:cNvPr id="2" name="TextBox 1"/>
+          <p:cNvSpPr txBox="1"/>
+          <p:nvPr/>
+        </p:nvSpPr>
+        <p:spPr>
+          <a:xfrm>
+            <a:off x="731520" y="731520"/>
+            <a:ext cx="10728655" cy="5394960"/>
+          </a:xfrm>
+          <a:prstGeom prst="rect">
+            <a:avLst/>
+          </a:prstGeom>
+          <a:noFill/>
+        </p:spPr>
+        <p:txBody>
+          <a:bodyPr wrap="square" anchor="ctr"/>
+          <a:lstStyle/>
+          <a:p>
+            <a:pPr algn="ctr"/>
+            <a:r>
+              <a:rPr sz="3200" b="0" i="0">
+                <a:solidFill>
+                  <a:srgbClr val="444444"/>
+                </a:solidFill>
+              </a:rPr>
+              <a:t>2. Se esquecer minha terra, Jerusalém, cidade santa! Se te esqueço Jerusalém, se paralise minha destra, minha língua se ate ao céu da boca, se a tua memória eu perder... se não colocá-la, Jerusalém, acima de toda alegria.</a:t>
+            </a:r>
+          </a:p>
+        </p:txBody>
+      </p:sp>
     </p:spTree>
   </p:cSld>
   <p:clrMapOvr>
@@ -4224,8 +4277,8 @@
         </p:nvSpPr>
         <p:spPr>
           <a:xfrm>
-            <a:off x="731520" y="2057400"/>
-            <a:ext cx="10728655" cy="2400300"/>
+            <a:off x="731520" y="731520"/>
+            <a:ext cx="10728655" cy="5394960"/>
           </a:xfrm>
           <a:prstGeom prst="rect">
             <a:avLst/>
@@ -4238,12 +4291,12 @@
           <a:p>
             <a:pPr algn="ctr"/>
             <a:r>
-              <a:rPr sz="5200" b="1">
+              <a:rPr sz="3600" b="1" i="0">
                 <a:solidFill>
                   <a:srgbClr val="1A1A1A"/>
                 </a:solidFill>
               </a:rPr>
-              <a:t>Santo</a:t>
+              <a:t>Nos rios da Babilônia estamos chorando ao recordar de Sião, ao recordar de Sião.</a:t>
             </a:r>
           </a:p>
         </p:txBody>
@@ -4320,7 +4373,7 @@
     <p:bg>
       <p:bgPr>
         <a:solidFill>
-          <a:srgbClr val="FAF9F7"/>
+          <a:srgbClr val="000000"/>
         </a:solidFill>
         <a:effectLst/>
       </p:bgPr>
@@ -4332,39 +4385,6 @@
         <p:nvPr/>
       </p:nvGrpSpPr>
       <p:grpSpPr/>
-      <p:sp>
-        <p:nvSpPr>
-          <p:cNvPr id="2" name="TextBox 1"/>
-          <p:cNvSpPr txBox="1"/>
-          <p:nvPr/>
-        </p:nvSpPr>
-        <p:spPr>
-          <a:xfrm>
-            <a:off x="731520" y="731520"/>
-            <a:ext cx="10728655" cy="5394960"/>
-          </a:xfrm>
-          <a:prstGeom prst="rect">
-            <a:avLst/>
-          </a:prstGeom>
-          <a:noFill/>
-        </p:spPr>
-        <p:txBody>
-          <a:bodyPr wrap="square" anchor="ctr"/>
-          <a:lstStyle/>
-          <a:p>
-            <a:pPr algn="ctr"/>
-            <a:r>
-              <a:rPr sz="3600" b="1" i="0">
-                <a:solidFill>
-                  <a:srgbClr val="1A1A1A"/>
-                </a:solidFill>
-              </a:rPr>
-              <a:t>Santo, Santo, Santo / é o Senhor Deus do universo
-Santo, Santo, Santo / é o Senhor Deus do universo</a:t>
-            </a:r>
-          </a:p>
-        </p:txBody>
-      </p:sp>
     </p:spTree>
   </p:cSld>
   <p:clrMapOvr>
@@ -4399,8 +4419,8 @@
         </p:nvSpPr>
         <p:spPr>
           <a:xfrm>
-            <a:off x="731520" y="731520"/>
-            <a:ext cx="10728655" cy="5394960"/>
+            <a:off x="731520" y="2057400"/>
+            <a:ext cx="10728655" cy="2400300"/>
           </a:xfrm>
           <a:prstGeom prst="rect">
             <a:avLst/>
@@ -4413,13 +4433,12 @@
           <a:p>
             <a:pPr algn="ctr"/>
             <a:r>
-              <a:rPr sz="3200" b="0" i="0">
-                <a:solidFill>
-                  <a:srgbClr val="444444"/>
+              <a:rPr sz="5200" b="1">
+                <a:solidFill>
+                  <a:srgbClr val="1A1A1A"/>
                 </a:solidFill>
               </a:rPr>
-              <a:t>O céu e a terra / proclamam a vossa glória
-Hosana, Hosana nas alturas</a:t>
+              <a:t>Ofertório</a:t>
             </a:r>
           </a:p>
         </p:txBody>
@@ -4477,7 +4496,7 @@
                   <a:srgbClr val="1A1A1A"/>
                 </a:solidFill>
               </a:rPr>
-              <a:t>Hosana, Hosana nas alturas</a:t>
+              <a:t>Pai, eu pequei contra o céu e contra ti, não sou digno de ser seu filho. Pai, piedade, piedade de mim. Pai, piedade, piedade de mim.</a:t>
             </a:r>
           </a:p>
         </p:txBody>
@@ -4535,8 +4554,7 @@
                   <a:srgbClr val="444444"/>
                 </a:solidFill>
               </a:rPr>
-              <a:t>Bendito o que vem / em nome do Senhor
-Hosana, Hosana nas alturas</a:t>
+              <a:t>1. Seu pai o viu quando ainda estava longe, ao vê-lo seu coração tremeu, então correu ao seu encontro, jogou-se em seu colo e o abraçou.</a:t>
             </a:r>
           </a:p>
         </p:txBody>
@@ -4594,7 +4612,7 @@
                   <a:srgbClr val="1A1A1A"/>
                 </a:solidFill>
               </a:rPr>
-              <a:t>Hosana, Hosana nas alturas</a:t>
+              <a:t>Pai, eu pequei contra o céu e contra ti, não sou digno de ser seu filho. Pai, piedade, piedade de mim. Pai, piedade, piedade de mim.</a:t>
             </a:r>
           </a:p>
         </p:txBody>
@@ -4613,7 +4631,7 @@
     <p:bg>
       <p:bgPr>
         <a:solidFill>
-          <a:srgbClr val="000000"/>
+          <a:srgbClr val="FAF9F7"/>
         </a:solidFill>
         <a:effectLst/>
       </p:bgPr>
@@ -4625,6 +4643,38 @@
         <p:nvPr/>
       </p:nvGrpSpPr>
       <p:grpSpPr/>
+      <p:sp>
+        <p:nvSpPr>
+          <p:cNvPr id="2" name="TextBox 1"/>
+          <p:cNvSpPr txBox="1"/>
+          <p:nvPr/>
+        </p:nvSpPr>
+        <p:spPr>
+          <a:xfrm>
+            <a:off x="731520" y="731520"/>
+            <a:ext cx="10728655" cy="5394960"/>
+          </a:xfrm>
+          <a:prstGeom prst="rect">
+            <a:avLst/>
+          </a:prstGeom>
+          <a:noFill/>
+        </p:spPr>
+        <p:txBody>
+          <a:bodyPr wrap="square" anchor="ctr"/>
+          <a:lstStyle/>
+          <a:p>
+            <a:pPr algn="ctr"/>
+            <a:r>
+              <a:rPr sz="3200" b="0" i="0">
+                <a:solidFill>
+                  <a:srgbClr val="444444"/>
+                </a:solidFill>
+              </a:rPr>
+              <a:t>2. O pai disse ao servo: tragam-me depressa, tragam aqui a veste mais bela, coloquem no dedo um anel, tragam calçados para ele.</a:t>
+            </a:r>
+          </a:p>
+        </p:txBody>
+      </p:sp>
     </p:spTree>
   </p:cSld>
   <p:clrMapOvr>
@@ -4659,8 +4709,8 @@
         </p:nvSpPr>
         <p:spPr>
           <a:xfrm>
-            <a:off x="731520" y="2057400"/>
-            <a:ext cx="10728655" cy="2400300"/>
+            <a:off x="731520" y="731520"/>
+            <a:ext cx="10728655" cy="5394960"/>
           </a:xfrm>
           <a:prstGeom prst="rect">
             <a:avLst/>
@@ -4673,12 +4723,12 @@
           <a:p>
             <a:pPr algn="ctr"/>
             <a:r>
-              <a:rPr sz="5200" b="1">
+              <a:rPr sz="3600" b="1" i="0">
                 <a:solidFill>
                   <a:srgbClr val="1A1A1A"/>
                 </a:solidFill>
               </a:rPr>
-              <a:t>Cordeiro</a:t>
+              <a:t>Pai, eu pequei contra o céu e contra ti, não sou digno de ser seu filho. Pai, piedade, piedade de mim. Pai, piedade, piedade de mim.</a:t>
             </a:r>
           </a:p>
         </p:txBody>
@@ -4736,7 +4786,7 @@
                   <a:srgbClr val="444444"/>
                 </a:solidFill>
               </a:rPr>
-              <a:t>Cordeiro de Deus, que tirais o pecado do mundo</a:t>
+              <a:t>3. Preparai logo um bezerro grande, vamos comer e fazer uma festa, meu filho que estava morto agora vive, estava perdido e está aqui.</a:t>
             </a:r>
           </a:p>
         </p:txBody>
@@ -4794,7 +4844,7 @@
                   <a:srgbClr val="1A1A1A"/>
                 </a:solidFill>
               </a:rPr>
-              <a:t>Tende piedade, piedade de nós.</a:t>
+              <a:t>Pai, eu pequei contra o céu e contra ti, não sou digno de ser seu filho. Pai, piedade, piedade de mim. Pai, piedade, piedade de mim.</a:t>
             </a:r>
           </a:p>
         </p:txBody>
@@ -4813,7 +4863,7 @@
     <p:bg>
       <p:bgPr>
         <a:solidFill>
-          <a:srgbClr val="FAF9F7"/>
+          <a:srgbClr val="000000"/>
         </a:solidFill>
         <a:effectLst/>
       </p:bgPr>
@@ -4825,38 +4875,6 @@
         <p:nvPr/>
       </p:nvGrpSpPr>
       <p:grpSpPr/>
-      <p:sp>
-        <p:nvSpPr>
-          <p:cNvPr id="2" name="TextBox 1"/>
-          <p:cNvSpPr txBox="1"/>
-          <p:nvPr/>
-        </p:nvSpPr>
-        <p:spPr>
-          <a:xfrm>
-            <a:off x="731520" y="731520"/>
-            <a:ext cx="10728655" cy="5394960"/>
-          </a:xfrm>
-          <a:prstGeom prst="rect">
-            <a:avLst/>
-          </a:prstGeom>
-          <a:noFill/>
-        </p:spPr>
-        <p:txBody>
-          <a:bodyPr wrap="square" anchor="ctr"/>
-          <a:lstStyle/>
-          <a:p>
-            <a:pPr algn="ctr"/>
-            <a:r>
-              <a:rPr sz="3200" b="0" i="0">
-                <a:solidFill>
-                  <a:srgbClr val="444444"/>
-                </a:solidFill>
-              </a:rPr>
-              <a:t>Cordeiro de Deus, que tirais o peca.do do mundo</a:t>
-            </a:r>
-          </a:p>
-        </p:txBody>
-      </p:sp>
     </p:spTree>
   </p:cSld>
   <p:clrMapOvr>
@@ -4905,9 +4923,9 @@
           <a:p>
             <a:pPr algn="ctr"/>
             <a:r>
-              <a:rPr sz="3200" b="0" i="0">
-                <a:solidFill>
-                  <a:srgbClr val="444444"/>
+              <a:rPr sz="3600" b="1" i="0">
+                <a:solidFill>
+                  <a:srgbClr val="1A1A1A"/>
                 </a:solidFill>
               </a:rPr>
               <a:t>Miserere mei, Domine. Miserere mei, Domine.</a:t>
@@ -4949,8 +4967,8 @@
         </p:nvSpPr>
         <p:spPr>
           <a:xfrm>
-            <a:off x="731520" y="731520"/>
-            <a:ext cx="10728655" cy="5394960"/>
+            <a:off x="731520" y="2057400"/>
+            <a:ext cx="10728655" cy="2400300"/>
           </a:xfrm>
           <a:prstGeom prst="rect">
             <a:avLst/>
@@ -4963,12 +4981,12 @@
           <a:p>
             <a:pPr algn="ctr"/>
             <a:r>
-              <a:rPr sz="3600" b="1" i="0">
+              <a:rPr sz="5200" b="1">
                 <a:solidFill>
                   <a:srgbClr val="1A1A1A"/>
                 </a:solidFill>
               </a:rPr>
-              <a:t>Tende piedade, piedade de nós.</a:t>
+              <a:t>Santo</a:t>
             </a:r>
           </a:p>
         </p:txBody>
@@ -5021,12 +5039,13 @@
           <a:p>
             <a:pPr algn="ctr"/>
             <a:r>
-              <a:rPr sz="3200" b="0" i="0">
-                <a:solidFill>
-                  <a:srgbClr val="444444"/>
+              <a:rPr sz="3600" b="1" i="0">
+                <a:solidFill>
+                  <a:srgbClr val="1A1A1A"/>
                 </a:solidFill>
               </a:rPr>
-              <a:t>Cordeiro de Deus, que tirais. o pecado do mundo</a:t>
+              <a:t>Santo, Santo, Santo / é o Senhor Deus do universo
+Santo, Santo, Santo / é o Senhor Deus do universo</a:t>
             </a:r>
           </a:p>
         </p:txBody>
@@ -5079,12 +5098,13 @@
           <a:p>
             <a:pPr algn="ctr"/>
             <a:r>
-              <a:rPr sz="3600" b="1" i="0">
-                <a:solidFill>
-                  <a:srgbClr val="1A1A1A"/>
+              <a:rPr sz="3200" b="0" i="0">
+                <a:solidFill>
+                  <a:srgbClr val="444444"/>
                 </a:solidFill>
               </a:rPr>
-              <a:t>Dai-nos a paz, dai-nos a paz</a:t>
+              <a:t>O céu e a terra / proclamam a vossa glória
+Hosana, Hosana nas alturas</a:t>
             </a:r>
           </a:p>
         </p:txBody>
@@ -5103,7 +5123,7 @@
     <p:bg>
       <p:bgPr>
         <a:solidFill>
-          <a:srgbClr val="000000"/>
+          <a:srgbClr val="FAF9F7"/>
         </a:solidFill>
         <a:effectLst/>
       </p:bgPr>
@@ -5115,6 +5135,38 @@
         <p:nvPr/>
       </p:nvGrpSpPr>
       <p:grpSpPr/>
+      <p:sp>
+        <p:nvSpPr>
+          <p:cNvPr id="2" name="TextBox 1"/>
+          <p:cNvSpPr txBox="1"/>
+          <p:nvPr/>
+        </p:nvSpPr>
+        <p:spPr>
+          <a:xfrm>
+            <a:off x="731520" y="731520"/>
+            <a:ext cx="10728655" cy="5394960"/>
+          </a:xfrm>
+          <a:prstGeom prst="rect">
+            <a:avLst/>
+          </a:prstGeom>
+          <a:noFill/>
+        </p:spPr>
+        <p:txBody>
+          <a:bodyPr wrap="square" anchor="ctr"/>
+          <a:lstStyle/>
+          <a:p>
+            <a:pPr algn="ctr"/>
+            <a:r>
+              <a:rPr sz="3600" b="1" i="0">
+                <a:solidFill>
+                  <a:srgbClr val="1A1A1A"/>
+                </a:solidFill>
+              </a:rPr>
+              <a:t>Hosana, Hosana nas alturas</a:t>
+            </a:r>
+          </a:p>
+        </p:txBody>
+      </p:sp>
     </p:spTree>
   </p:cSld>
   <p:clrMapOvr>
@@ -5149,8 +5201,8 @@
         </p:nvSpPr>
         <p:spPr>
           <a:xfrm>
-            <a:off x="731520" y="2057400"/>
-            <a:ext cx="10728655" cy="2400300"/>
+            <a:off x="731520" y="731520"/>
+            <a:ext cx="10728655" cy="5394960"/>
           </a:xfrm>
           <a:prstGeom prst="rect">
             <a:avLst/>
@@ -5163,12 +5215,13 @@
           <a:p>
             <a:pPr algn="ctr"/>
             <a:r>
-              <a:rPr sz="5200" b="1">
-                <a:solidFill>
-                  <a:srgbClr val="1A1A1A"/>
+              <a:rPr sz="3200" b="0" i="0">
+                <a:solidFill>
+                  <a:srgbClr val="444444"/>
                 </a:solidFill>
               </a:rPr>
-              <a:t>Comunhão</a:t>
+              <a:t>Bendito o que vem / em nome do Senhor
+Hosana, Hosana nas alturas</a:t>
             </a:r>
           </a:p>
         </p:txBody>
@@ -5226,7 +5279,7 @@
                   <a:srgbClr val="1A1A1A"/>
                 </a:solidFill>
               </a:rPr>
-              <a:t>Feliz aquele a quem o Senhor perdoa o pecado, feliz aquele a quem o Senhor perdoa o pecado.</a:t>
+              <a:t>Hosana, Hosana nas alturas</a:t>
             </a:r>
           </a:p>
         </p:txBody>
@@ -5245,7 +5298,7 @@
     <p:bg>
       <p:bgPr>
         <a:solidFill>
-          <a:srgbClr val="FAF9F7"/>
+          <a:srgbClr val="000000"/>
         </a:solidFill>
         <a:effectLst/>
       </p:bgPr>
@@ -5257,38 +5310,6 @@
         <p:nvPr/>
       </p:nvGrpSpPr>
       <p:grpSpPr/>
-      <p:sp>
-        <p:nvSpPr>
-          <p:cNvPr id="2" name="TextBox 1"/>
-          <p:cNvSpPr txBox="1"/>
-          <p:nvPr/>
-        </p:nvSpPr>
-        <p:spPr>
-          <a:xfrm>
-            <a:off x="731520" y="731520"/>
-            <a:ext cx="10728655" cy="5394960"/>
-          </a:xfrm>
-          <a:prstGeom prst="rect">
-            <a:avLst/>
-          </a:prstGeom>
-          <a:noFill/>
-        </p:spPr>
-        <p:txBody>
-          <a:bodyPr wrap="square" anchor="ctr"/>
-          <a:lstStyle/>
-          <a:p>
-            <a:pPr algn="ctr"/>
-            <a:r>
-              <a:rPr sz="3200" b="0" i="0">
-                <a:solidFill>
-                  <a:srgbClr val="444444"/>
-                </a:solidFill>
-              </a:rPr>
-              <a:t>1. Feliz o homem limpo de toda culpa, no coração é apagado o pecado.2. Eu revelei toda a minha culpa, iniquidade e pecado confesso.3. És meu refúgio, me livra da angústia, me cerca de cantos de libertação.</a:t>
-            </a:r>
-          </a:p>
-        </p:txBody>
-      </p:sp>
     </p:spTree>
   </p:cSld>
   <p:clrMapOvr>
@@ -5323,8 +5344,8 @@
         </p:nvSpPr>
         <p:spPr>
           <a:xfrm>
-            <a:off x="731520" y="731520"/>
-            <a:ext cx="10728655" cy="5394960"/>
+            <a:off x="731520" y="2057400"/>
+            <a:ext cx="10728655" cy="2400300"/>
           </a:xfrm>
           <a:prstGeom prst="rect">
             <a:avLst/>
@@ -5337,12 +5358,12 @@
           <a:p>
             <a:pPr algn="ctr"/>
             <a:r>
-              <a:rPr sz="3600" b="1" i="0">
+              <a:rPr sz="5200" b="1">
                 <a:solidFill>
                   <a:srgbClr val="1A1A1A"/>
                 </a:solidFill>
               </a:rPr>
-              <a:t>Feliz aquele a quem o Senhor perdoa o pecado, feliz aquele a quem o Senhor perdoa o pecado.</a:t>
+              <a:t>Cordeiro</a:t>
             </a:r>
           </a:p>
         </p:txBody>
@@ -5361,7 +5382,7 @@
     <p:bg>
       <p:bgPr>
         <a:solidFill>
-          <a:srgbClr val="000000"/>
+          <a:srgbClr val="FAF9F7"/>
         </a:solidFill>
         <a:effectLst/>
       </p:bgPr>
@@ -5373,6 +5394,38 @@
         <p:nvPr/>
       </p:nvGrpSpPr>
       <p:grpSpPr/>
+      <p:sp>
+        <p:nvSpPr>
+          <p:cNvPr id="2" name="TextBox 1"/>
+          <p:cNvSpPr txBox="1"/>
+          <p:nvPr/>
+        </p:nvSpPr>
+        <p:spPr>
+          <a:xfrm>
+            <a:off x="731520" y="731520"/>
+            <a:ext cx="10728655" cy="5394960"/>
+          </a:xfrm>
+          <a:prstGeom prst="rect">
+            <a:avLst/>
+          </a:prstGeom>
+          <a:noFill/>
+        </p:spPr>
+        <p:txBody>
+          <a:bodyPr wrap="square" anchor="ctr"/>
+          <a:lstStyle/>
+          <a:p>
+            <a:pPr algn="ctr"/>
+            <a:r>
+              <a:rPr sz="3200" b="0" i="0">
+                <a:solidFill>
+                  <a:srgbClr val="444444"/>
+                </a:solidFill>
+              </a:rPr>
+              <a:t>Cordeiro de Deus, que tirais o pecado do mundo</a:t>
+            </a:r>
+          </a:p>
+        </p:txBody>
+      </p:sp>
     </p:spTree>
   </p:cSld>
   <p:clrMapOvr>
@@ -5407,8 +5460,8 @@
         </p:nvSpPr>
         <p:spPr>
           <a:xfrm>
-            <a:off x="731520" y="2057400"/>
-            <a:ext cx="10728655" cy="2400300"/>
+            <a:off x="731520" y="731520"/>
+            <a:ext cx="10728655" cy="5394960"/>
           </a:xfrm>
           <a:prstGeom prst="rect">
             <a:avLst/>
@@ -5421,12 +5474,12 @@
           <a:p>
             <a:pPr algn="ctr"/>
             <a:r>
-              <a:rPr sz="5200" b="1">
+              <a:rPr sz="3600" b="1" i="0">
                 <a:solidFill>
                   <a:srgbClr val="1A1A1A"/>
                 </a:solidFill>
               </a:rPr>
-              <a:t>Final</a:t>
+              <a:t>Tende piedade, piedade de nós.</a:t>
             </a:r>
           </a:p>
         </p:txBody>
@@ -5484,7 +5537,7 @@
                   <a:srgbClr val="444444"/>
                 </a:solidFill>
               </a:rPr>
-              <a:t>Piedade de mim, ó meu Deus, misericórdia. Na imensidão do amor, purificai-me. Lavai-me todo inteiro do pecado, apagai totalmente minha culpa.</a:t>
+              <a:t>1. Piedade de mim, ó meu Deus, misericórdia. Na imensidão do amor, purificai-me. Lavai-me todo inteiro do pecado, apagai totalmente minha culpa.</a:t>
             </a:r>
           </a:p>
         </p:txBody>
@@ -5537,12 +5590,12 @@
           <a:p>
             <a:pPr algn="ctr"/>
             <a:r>
-              <a:rPr sz="3600" b="1" i="0">
-                <a:solidFill>
-                  <a:srgbClr val="1A1A1A"/>
+              <a:rPr sz="3200" b="0" i="0">
+                <a:solidFill>
+                  <a:srgbClr val="444444"/>
                 </a:solidFill>
               </a:rPr>
-              <a:t>Quando Israel saiu do Egito, a casa de Jacó era um povo bárbaro, Judá tornou-se o seu santuário, Israel seu domínio.</a:t>
+              <a:t>Cordeiro de Deus, que tirais o peca.do do mundo</a:t>
             </a:r>
           </a:p>
         </p:txBody>
@@ -5595,12 +5648,12 @@
           <a:p>
             <a:pPr algn="ctr"/>
             <a:r>
-              <a:rPr sz="3200" b="0" i="0">
-                <a:solidFill>
-                  <a:srgbClr val="444444"/>
+              <a:rPr sz="3600" b="1" i="0">
+                <a:solidFill>
+                  <a:srgbClr val="1A1A1A"/>
                 </a:solidFill>
               </a:rPr>
-              <a:t>O mar viu e se retirou, o Jordão voltou atrás, os montes saltaram como carneiros, as colinas como um rebanho.</a:t>
+              <a:t>Tende piedade, piedade de nós.</a:t>
             </a:r>
           </a:p>
         </p:txBody>
@@ -5653,12 +5706,12 @@
           <a:p>
             <a:pPr algn="ctr"/>
             <a:r>
-              <a:rPr sz="3600" b="1" i="0">
-                <a:solidFill>
-                  <a:srgbClr val="1A1A1A"/>
+              <a:rPr sz="3200" b="0" i="0">
+                <a:solidFill>
+                  <a:srgbClr val="444444"/>
                 </a:solidFill>
               </a:rPr>
-              <a:t>Quando Israel saiu do Egito, a casa de Jacó era um povo bárbaro, Judá tornou-se o seu santuário, Israel seu domínio.</a:t>
+              <a:t>Cordeiro de Deus, que tirais. o pecado do mundo</a:t>
             </a:r>
           </a:p>
         </p:txBody>
@@ -5711,12 +5764,12 @@
           <a:p>
             <a:pPr algn="ctr"/>
             <a:r>
-              <a:rPr sz="3200" b="0" i="0">
-                <a:solidFill>
-                  <a:srgbClr val="444444"/>
+              <a:rPr sz="3600" b="1" i="0">
+                <a:solidFill>
+                  <a:srgbClr val="1A1A1A"/>
                 </a:solidFill>
               </a:rPr>
-              <a:t>O que tem, mar, para fugir? E tu, Jordão, por que voltas? Por que vós, montes, saltam como um cordeiro no rebanho?</a:t>
+              <a:t>Dai-nos a paz, dai-nos a paz</a:t>
             </a:r>
           </a:p>
         </p:txBody>
@@ -5735,7 +5788,7 @@
     <p:bg>
       <p:bgPr>
         <a:solidFill>
-          <a:srgbClr val="FAF9F7"/>
+          <a:srgbClr val="000000"/>
         </a:solidFill>
         <a:effectLst/>
       </p:bgPr>
@@ -5747,38 +5800,6 @@
         <p:nvPr/>
       </p:nvGrpSpPr>
       <p:grpSpPr/>
-      <p:sp>
-        <p:nvSpPr>
-          <p:cNvPr id="2" name="TextBox 1"/>
-          <p:cNvSpPr txBox="1"/>
-          <p:nvPr/>
-        </p:nvSpPr>
-        <p:spPr>
-          <a:xfrm>
-            <a:off x="731520" y="731520"/>
-            <a:ext cx="10728655" cy="5394960"/>
-          </a:xfrm>
-          <a:prstGeom prst="rect">
-            <a:avLst/>
-          </a:prstGeom>
-          <a:noFill/>
-        </p:spPr>
-        <p:txBody>
-          <a:bodyPr wrap="square" anchor="ctr"/>
-          <a:lstStyle/>
-          <a:p>
-            <a:pPr algn="ctr"/>
-            <a:r>
-              <a:rPr sz="3600" b="1" i="0">
-                <a:solidFill>
-                  <a:srgbClr val="1A1A1A"/>
-                </a:solidFill>
-              </a:rPr>
-              <a:t>Quando Israel saiu do Egito, a casa de Jacó era um povo bárbaro, Judá tornou-se o seu santuário, Israel seu domínio.</a:t>
-            </a:r>
-          </a:p>
-        </p:txBody>
-      </p:sp>
     </p:spTree>
   </p:cSld>
   <p:clrMapOvr>
@@ -5813,8 +5834,8 @@
         </p:nvSpPr>
         <p:spPr>
           <a:xfrm>
-            <a:off x="731520" y="731520"/>
-            <a:ext cx="10728655" cy="5394960"/>
+            <a:off x="731520" y="2057400"/>
+            <a:ext cx="10728655" cy="2400300"/>
           </a:xfrm>
           <a:prstGeom prst="rect">
             <a:avLst/>
@@ -5827,12 +5848,12 @@
           <a:p>
             <a:pPr algn="ctr"/>
             <a:r>
-              <a:rPr sz="3200" b="0" i="0">
-                <a:solidFill>
-                  <a:srgbClr val="444444"/>
+              <a:rPr sz="5200" b="1">
+                <a:solidFill>
+                  <a:srgbClr val="1A1A1A"/>
                 </a:solidFill>
               </a:rPr>
-              <a:t>Trema, ó terra, diante do Senhor, diante do Deus de Jacó, que muda o abismo em lago, a rocha em fonte de água.</a:t>
+              <a:t>Comunhão</a:t>
             </a:r>
           </a:p>
         </p:txBody>
@@ -5890,7 +5911,181 @@
                   <a:srgbClr val="1A1A1A"/>
                 </a:solidFill>
               </a:rPr>
-              <a:t>Quando Israel saiu do Egito, a casa de Jacó era um povo bárbaro, Judá tornou-se o seu santuário, Israel seu domínio.</a:t>
+              <a:t>Feliz aquele a quem o Senhor perdoa o pecado, feliz aquele a quem o Senhor perdoa o pecado.</a:t>
+            </a:r>
+          </a:p>
+        </p:txBody>
+      </p:sp>
+    </p:spTree>
+  </p:cSld>
+  <p:clrMapOvr>
+    <a:masterClrMapping/>
+  </p:clrMapOvr>
+</p:sld>
+</file>
+
+<file path=ppt/slides/slide57.xml><?xml version="1.0" encoding="utf-8"?>
+<p:sld xmlns:a="http://schemas.openxmlformats.org/drawingml/2006/main" xmlns:p="http://schemas.openxmlformats.org/presentationml/2006/main" xmlns:r="http://schemas.openxmlformats.org/officeDocument/2006/relationships">
+  <p:cSld>
+    <p:bg>
+      <p:bgPr>
+        <a:solidFill>
+          <a:srgbClr val="FAF9F7"/>
+        </a:solidFill>
+        <a:effectLst/>
+      </p:bgPr>
+    </p:bg>
+    <p:spTree>
+      <p:nvGrpSpPr>
+        <p:cNvPr id="1" name=""/>
+        <p:cNvGrpSpPr/>
+        <p:nvPr/>
+      </p:nvGrpSpPr>
+      <p:grpSpPr/>
+      <p:sp>
+        <p:nvSpPr>
+          <p:cNvPr id="2" name="TextBox 1"/>
+          <p:cNvSpPr txBox="1"/>
+          <p:nvPr/>
+        </p:nvSpPr>
+        <p:spPr>
+          <a:xfrm>
+            <a:off x="731520" y="731520"/>
+            <a:ext cx="10728655" cy="5394960"/>
+          </a:xfrm>
+          <a:prstGeom prst="rect">
+            <a:avLst/>
+          </a:prstGeom>
+          <a:noFill/>
+        </p:spPr>
+        <p:txBody>
+          <a:bodyPr wrap="square" anchor="ctr"/>
+          <a:lstStyle/>
+          <a:p>
+            <a:pPr algn="ctr"/>
+            <a:r>
+              <a:rPr sz="3200" b="0" i="0">
+                <a:solidFill>
+                  <a:srgbClr val="444444"/>
+                </a:solidFill>
+              </a:rPr>
+              <a:t>1. Feliz o homem limpo de toda culpa, no coração é apagado o pecado.</a:t>
+            </a:r>
+          </a:p>
+        </p:txBody>
+      </p:sp>
+    </p:spTree>
+  </p:cSld>
+  <p:clrMapOvr>
+    <a:masterClrMapping/>
+  </p:clrMapOvr>
+</p:sld>
+</file>
+
+<file path=ppt/slides/slide58.xml><?xml version="1.0" encoding="utf-8"?>
+<p:sld xmlns:a="http://schemas.openxmlformats.org/drawingml/2006/main" xmlns:p="http://schemas.openxmlformats.org/presentationml/2006/main" xmlns:r="http://schemas.openxmlformats.org/officeDocument/2006/relationships">
+  <p:cSld>
+    <p:bg>
+      <p:bgPr>
+        <a:solidFill>
+          <a:srgbClr val="FAF9F7"/>
+        </a:solidFill>
+        <a:effectLst/>
+      </p:bgPr>
+    </p:bg>
+    <p:spTree>
+      <p:nvGrpSpPr>
+        <p:cNvPr id="1" name=""/>
+        <p:cNvGrpSpPr/>
+        <p:nvPr/>
+      </p:nvGrpSpPr>
+      <p:grpSpPr/>
+      <p:sp>
+        <p:nvSpPr>
+          <p:cNvPr id="2" name="TextBox 1"/>
+          <p:cNvSpPr txBox="1"/>
+          <p:nvPr/>
+        </p:nvSpPr>
+        <p:spPr>
+          <a:xfrm>
+            <a:off x="731520" y="731520"/>
+            <a:ext cx="10728655" cy="5394960"/>
+          </a:xfrm>
+          <a:prstGeom prst="rect">
+            <a:avLst/>
+          </a:prstGeom>
+          <a:noFill/>
+        </p:spPr>
+        <p:txBody>
+          <a:bodyPr wrap="square" anchor="ctr"/>
+          <a:lstStyle/>
+          <a:p>
+            <a:pPr algn="ctr"/>
+            <a:r>
+              <a:rPr sz="3600" b="1" i="0">
+                <a:solidFill>
+                  <a:srgbClr val="1A1A1A"/>
+                </a:solidFill>
+              </a:rPr>
+              <a:t>Feliz aquele a quem o Senhor perdoa o pecado, feliz aquele a quem o Senhor perdoa o pecado.</a:t>
+            </a:r>
+          </a:p>
+        </p:txBody>
+      </p:sp>
+    </p:spTree>
+  </p:cSld>
+  <p:clrMapOvr>
+    <a:masterClrMapping/>
+  </p:clrMapOvr>
+</p:sld>
+</file>
+
+<file path=ppt/slides/slide59.xml><?xml version="1.0" encoding="utf-8"?>
+<p:sld xmlns:a="http://schemas.openxmlformats.org/drawingml/2006/main" xmlns:p="http://schemas.openxmlformats.org/presentationml/2006/main" xmlns:r="http://schemas.openxmlformats.org/officeDocument/2006/relationships">
+  <p:cSld>
+    <p:bg>
+      <p:bgPr>
+        <a:solidFill>
+          <a:srgbClr val="FAF9F7"/>
+        </a:solidFill>
+        <a:effectLst/>
+      </p:bgPr>
+    </p:bg>
+    <p:spTree>
+      <p:nvGrpSpPr>
+        <p:cNvPr id="1" name=""/>
+        <p:cNvGrpSpPr/>
+        <p:nvPr/>
+      </p:nvGrpSpPr>
+      <p:grpSpPr/>
+      <p:sp>
+        <p:nvSpPr>
+          <p:cNvPr id="2" name="TextBox 1"/>
+          <p:cNvSpPr txBox="1"/>
+          <p:nvPr/>
+        </p:nvSpPr>
+        <p:spPr>
+          <a:xfrm>
+            <a:off x="731520" y="731520"/>
+            <a:ext cx="10728655" cy="5394960"/>
+          </a:xfrm>
+          <a:prstGeom prst="rect">
+            <a:avLst/>
+          </a:prstGeom>
+          <a:noFill/>
+        </p:spPr>
+        <p:txBody>
+          <a:bodyPr wrap="square" anchor="ctr"/>
+          <a:lstStyle/>
+          <a:p>
+            <a:pPr algn="ctr"/>
+            <a:r>
+              <a:rPr sz="3200" b="0" i="0">
+                <a:solidFill>
+                  <a:srgbClr val="444444"/>
+                </a:solidFill>
+              </a:rPr>
+              <a:t>2. Eu revelei toda a minha culpa, iniquidade e pecado confesso.</a:t>
             </a:r>
           </a:p>
         </p:txBody>
@@ -5943,12 +6138,560 @@
           <a:p>
             <a:pPr algn="ctr"/>
             <a:r>
+              <a:rPr sz="3600" b="1" i="0">
+                <a:solidFill>
+                  <a:srgbClr val="1A1A1A"/>
+                </a:solidFill>
+              </a:rPr>
+              <a:t>Miserere mei, Domine. Miserere mei, Domine.</a:t>
+            </a:r>
+          </a:p>
+        </p:txBody>
+      </p:sp>
+    </p:spTree>
+  </p:cSld>
+  <p:clrMapOvr>
+    <a:masterClrMapping/>
+  </p:clrMapOvr>
+</p:sld>
+</file>
+
+<file path=ppt/slides/slide60.xml><?xml version="1.0" encoding="utf-8"?>
+<p:sld xmlns:a="http://schemas.openxmlformats.org/drawingml/2006/main" xmlns:p="http://schemas.openxmlformats.org/presentationml/2006/main" xmlns:r="http://schemas.openxmlformats.org/officeDocument/2006/relationships">
+  <p:cSld>
+    <p:bg>
+      <p:bgPr>
+        <a:solidFill>
+          <a:srgbClr val="FAF9F7"/>
+        </a:solidFill>
+        <a:effectLst/>
+      </p:bgPr>
+    </p:bg>
+    <p:spTree>
+      <p:nvGrpSpPr>
+        <p:cNvPr id="1" name=""/>
+        <p:cNvGrpSpPr/>
+        <p:nvPr/>
+      </p:nvGrpSpPr>
+      <p:grpSpPr/>
+      <p:sp>
+        <p:nvSpPr>
+          <p:cNvPr id="2" name="TextBox 1"/>
+          <p:cNvSpPr txBox="1"/>
+          <p:nvPr/>
+        </p:nvSpPr>
+        <p:spPr>
+          <a:xfrm>
+            <a:off x="731520" y="731520"/>
+            <a:ext cx="10728655" cy="5394960"/>
+          </a:xfrm>
+          <a:prstGeom prst="rect">
+            <a:avLst/>
+          </a:prstGeom>
+          <a:noFill/>
+        </p:spPr>
+        <p:txBody>
+          <a:bodyPr wrap="square" anchor="ctr"/>
+          <a:lstStyle/>
+          <a:p>
+            <a:pPr algn="ctr"/>
+            <a:r>
+              <a:rPr sz="3600" b="1" i="0">
+                <a:solidFill>
+                  <a:srgbClr val="1A1A1A"/>
+                </a:solidFill>
+              </a:rPr>
+              <a:t>Feliz aquele a quem o Senhor perdoa o pecado, feliz aquele a quem o Senhor perdoa o pecado.</a:t>
+            </a:r>
+          </a:p>
+        </p:txBody>
+      </p:sp>
+    </p:spTree>
+  </p:cSld>
+  <p:clrMapOvr>
+    <a:masterClrMapping/>
+  </p:clrMapOvr>
+</p:sld>
+</file>
+
+<file path=ppt/slides/slide61.xml><?xml version="1.0" encoding="utf-8"?>
+<p:sld xmlns:a="http://schemas.openxmlformats.org/drawingml/2006/main" xmlns:p="http://schemas.openxmlformats.org/presentationml/2006/main" xmlns:r="http://schemas.openxmlformats.org/officeDocument/2006/relationships">
+  <p:cSld>
+    <p:bg>
+      <p:bgPr>
+        <a:solidFill>
+          <a:srgbClr val="FAF9F7"/>
+        </a:solidFill>
+        <a:effectLst/>
+      </p:bgPr>
+    </p:bg>
+    <p:spTree>
+      <p:nvGrpSpPr>
+        <p:cNvPr id="1" name=""/>
+        <p:cNvGrpSpPr/>
+        <p:nvPr/>
+      </p:nvGrpSpPr>
+      <p:grpSpPr/>
+      <p:sp>
+        <p:nvSpPr>
+          <p:cNvPr id="2" name="TextBox 1"/>
+          <p:cNvSpPr txBox="1"/>
+          <p:nvPr/>
+        </p:nvSpPr>
+        <p:spPr>
+          <a:xfrm>
+            <a:off x="731520" y="731520"/>
+            <a:ext cx="10728655" cy="5394960"/>
+          </a:xfrm>
+          <a:prstGeom prst="rect">
+            <a:avLst/>
+          </a:prstGeom>
+          <a:noFill/>
+        </p:spPr>
+        <p:txBody>
+          <a:bodyPr wrap="square" anchor="ctr"/>
+          <a:lstStyle/>
+          <a:p>
+            <a:pPr algn="ctr"/>
+            <a:r>
               <a:rPr sz="3200" b="0" i="0">
                 <a:solidFill>
                   <a:srgbClr val="444444"/>
                 </a:solidFill>
               </a:rPr>
-              <a:t>Eu reconheço toda a minha iniquidade, o meu pecado está sempre à minha frente. Foi contra vós somente que eu pequei e pratiquei o que é mau aos vossos olhos.</a:t>
+              <a:t>3. És meu refúgio, me livra da angústia, me cerca de cantos de libertação.</a:t>
+            </a:r>
+          </a:p>
+        </p:txBody>
+      </p:sp>
+    </p:spTree>
+  </p:cSld>
+  <p:clrMapOvr>
+    <a:masterClrMapping/>
+  </p:clrMapOvr>
+</p:sld>
+</file>
+
+<file path=ppt/slides/slide62.xml><?xml version="1.0" encoding="utf-8"?>
+<p:sld xmlns:a="http://schemas.openxmlformats.org/drawingml/2006/main" xmlns:p="http://schemas.openxmlformats.org/presentationml/2006/main" xmlns:r="http://schemas.openxmlformats.org/officeDocument/2006/relationships">
+  <p:cSld>
+    <p:bg>
+      <p:bgPr>
+        <a:solidFill>
+          <a:srgbClr val="FAF9F7"/>
+        </a:solidFill>
+        <a:effectLst/>
+      </p:bgPr>
+    </p:bg>
+    <p:spTree>
+      <p:nvGrpSpPr>
+        <p:cNvPr id="1" name=""/>
+        <p:cNvGrpSpPr/>
+        <p:nvPr/>
+      </p:nvGrpSpPr>
+      <p:grpSpPr/>
+      <p:sp>
+        <p:nvSpPr>
+          <p:cNvPr id="2" name="TextBox 1"/>
+          <p:cNvSpPr txBox="1"/>
+          <p:nvPr/>
+        </p:nvSpPr>
+        <p:spPr>
+          <a:xfrm>
+            <a:off x="731520" y="731520"/>
+            <a:ext cx="10728655" cy="5394960"/>
+          </a:xfrm>
+          <a:prstGeom prst="rect">
+            <a:avLst/>
+          </a:prstGeom>
+          <a:noFill/>
+        </p:spPr>
+        <p:txBody>
+          <a:bodyPr wrap="square" anchor="ctr"/>
+          <a:lstStyle/>
+          <a:p>
+            <a:pPr algn="ctr"/>
+            <a:r>
+              <a:rPr sz="3600" b="1" i="0">
+                <a:solidFill>
+                  <a:srgbClr val="1A1A1A"/>
+                </a:solidFill>
+              </a:rPr>
+              <a:t>Feliz aquele a quem o Senhor perdoa o pecado, feliz aquele a quem o Senhor perdoa o pecado.</a:t>
+            </a:r>
+          </a:p>
+        </p:txBody>
+      </p:sp>
+    </p:spTree>
+  </p:cSld>
+  <p:clrMapOvr>
+    <a:masterClrMapping/>
+  </p:clrMapOvr>
+</p:sld>
+</file>
+
+<file path=ppt/slides/slide63.xml><?xml version="1.0" encoding="utf-8"?>
+<p:sld xmlns:a="http://schemas.openxmlformats.org/drawingml/2006/main" xmlns:p="http://schemas.openxmlformats.org/presentationml/2006/main" xmlns:r="http://schemas.openxmlformats.org/officeDocument/2006/relationships">
+  <p:cSld>
+    <p:bg>
+      <p:bgPr>
+        <a:solidFill>
+          <a:srgbClr val="000000"/>
+        </a:solidFill>
+        <a:effectLst/>
+      </p:bgPr>
+    </p:bg>
+    <p:spTree>
+      <p:nvGrpSpPr>
+        <p:cNvPr id="1" name=""/>
+        <p:cNvGrpSpPr/>
+        <p:nvPr/>
+      </p:nvGrpSpPr>
+      <p:grpSpPr/>
+    </p:spTree>
+  </p:cSld>
+  <p:clrMapOvr>
+    <a:masterClrMapping/>
+  </p:clrMapOvr>
+</p:sld>
+</file>
+
+<file path=ppt/slides/slide64.xml><?xml version="1.0" encoding="utf-8"?>
+<p:sld xmlns:a="http://schemas.openxmlformats.org/drawingml/2006/main" xmlns:p="http://schemas.openxmlformats.org/presentationml/2006/main" xmlns:r="http://schemas.openxmlformats.org/officeDocument/2006/relationships">
+  <p:cSld>
+    <p:bg>
+      <p:bgPr>
+        <a:solidFill>
+          <a:srgbClr val="FAF9F7"/>
+        </a:solidFill>
+        <a:effectLst/>
+      </p:bgPr>
+    </p:bg>
+    <p:spTree>
+      <p:nvGrpSpPr>
+        <p:cNvPr id="1" name=""/>
+        <p:cNvGrpSpPr/>
+        <p:nvPr/>
+      </p:nvGrpSpPr>
+      <p:grpSpPr/>
+      <p:sp>
+        <p:nvSpPr>
+          <p:cNvPr id="2" name="TextBox 1"/>
+          <p:cNvSpPr txBox="1"/>
+          <p:nvPr/>
+        </p:nvSpPr>
+        <p:spPr>
+          <a:xfrm>
+            <a:off x="731520" y="2057400"/>
+            <a:ext cx="10728655" cy="2400300"/>
+          </a:xfrm>
+          <a:prstGeom prst="rect">
+            <a:avLst/>
+          </a:prstGeom>
+          <a:noFill/>
+        </p:spPr>
+        <p:txBody>
+          <a:bodyPr wrap="square" anchor="ctr"/>
+          <a:lstStyle/>
+          <a:p>
+            <a:pPr algn="ctr"/>
+            <a:r>
+              <a:rPr sz="5200" b="1">
+                <a:solidFill>
+                  <a:srgbClr val="1A1A1A"/>
+                </a:solidFill>
+              </a:rPr>
+              <a:t>Final</a:t>
+            </a:r>
+          </a:p>
+        </p:txBody>
+      </p:sp>
+    </p:spTree>
+  </p:cSld>
+  <p:clrMapOvr>
+    <a:masterClrMapping/>
+  </p:clrMapOvr>
+</p:sld>
+</file>
+
+<file path=ppt/slides/slide65.xml><?xml version="1.0" encoding="utf-8"?>
+<p:sld xmlns:a="http://schemas.openxmlformats.org/drawingml/2006/main" xmlns:p="http://schemas.openxmlformats.org/presentationml/2006/main" xmlns:r="http://schemas.openxmlformats.org/officeDocument/2006/relationships">
+  <p:cSld>
+    <p:bg>
+      <p:bgPr>
+        <a:solidFill>
+          <a:srgbClr val="FAF9F7"/>
+        </a:solidFill>
+        <a:effectLst/>
+      </p:bgPr>
+    </p:bg>
+    <p:spTree>
+      <p:nvGrpSpPr>
+        <p:cNvPr id="1" name=""/>
+        <p:cNvGrpSpPr/>
+        <p:nvPr/>
+      </p:nvGrpSpPr>
+      <p:grpSpPr/>
+      <p:sp>
+        <p:nvSpPr>
+          <p:cNvPr id="2" name="TextBox 1"/>
+          <p:cNvSpPr txBox="1"/>
+          <p:nvPr/>
+        </p:nvSpPr>
+        <p:spPr>
+          <a:xfrm>
+            <a:off x="731520" y="731520"/>
+            <a:ext cx="10728655" cy="5394960"/>
+          </a:xfrm>
+          <a:prstGeom prst="rect">
+            <a:avLst/>
+          </a:prstGeom>
+          <a:noFill/>
+        </p:spPr>
+        <p:txBody>
+          <a:bodyPr wrap="square" anchor="ctr"/>
+          <a:lstStyle/>
+          <a:p>
+            <a:pPr algn="ctr"/>
+            <a:r>
+              <a:rPr sz="3600" b="1" i="0">
+                <a:solidFill>
+                  <a:srgbClr val="1A1A1A"/>
+                </a:solidFill>
+              </a:rPr>
+              <a:t>Quando Israel saiu do Egito, a casa de Jacó era um povo bárbaro, Judá tornou-se o seu santuário, Israel seu domínio.</a:t>
+            </a:r>
+          </a:p>
+        </p:txBody>
+      </p:sp>
+    </p:spTree>
+  </p:cSld>
+  <p:clrMapOvr>
+    <a:masterClrMapping/>
+  </p:clrMapOvr>
+</p:sld>
+</file>
+
+<file path=ppt/slides/slide66.xml><?xml version="1.0" encoding="utf-8"?>
+<p:sld xmlns:a="http://schemas.openxmlformats.org/drawingml/2006/main" xmlns:p="http://schemas.openxmlformats.org/presentationml/2006/main" xmlns:r="http://schemas.openxmlformats.org/officeDocument/2006/relationships">
+  <p:cSld>
+    <p:bg>
+      <p:bgPr>
+        <a:solidFill>
+          <a:srgbClr val="FAF9F7"/>
+        </a:solidFill>
+        <a:effectLst/>
+      </p:bgPr>
+    </p:bg>
+    <p:spTree>
+      <p:nvGrpSpPr>
+        <p:cNvPr id="1" name=""/>
+        <p:cNvGrpSpPr/>
+        <p:nvPr/>
+      </p:nvGrpSpPr>
+      <p:grpSpPr/>
+      <p:sp>
+        <p:nvSpPr>
+          <p:cNvPr id="2" name="TextBox 1"/>
+          <p:cNvSpPr txBox="1"/>
+          <p:nvPr/>
+        </p:nvSpPr>
+        <p:spPr>
+          <a:xfrm>
+            <a:off x="731520" y="731520"/>
+            <a:ext cx="10728655" cy="5394960"/>
+          </a:xfrm>
+          <a:prstGeom prst="rect">
+            <a:avLst/>
+          </a:prstGeom>
+          <a:noFill/>
+        </p:spPr>
+        <p:txBody>
+          <a:bodyPr wrap="square" anchor="ctr"/>
+          <a:lstStyle/>
+          <a:p>
+            <a:pPr algn="ctr"/>
+            <a:r>
+              <a:rPr sz="3200" b="0" i="0">
+                <a:solidFill>
+                  <a:srgbClr val="444444"/>
+                </a:solidFill>
+              </a:rPr>
+              <a:t>O mar viu e se retirou, o Jordão voltou atrás, os montes saltaram como carneiros, as colinas como um rebanho.</a:t>
+            </a:r>
+          </a:p>
+        </p:txBody>
+      </p:sp>
+    </p:spTree>
+  </p:cSld>
+  <p:clrMapOvr>
+    <a:masterClrMapping/>
+  </p:clrMapOvr>
+</p:sld>
+</file>
+
+<file path=ppt/slides/slide67.xml><?xml version="1.0" encoding="utf-8"?>
+<p:sld xmlns:a="http://schemas.openxmlformats.org/drawingml/2006/main" xmlns:p="http://schemas.openxmlformats.org/presentationml/2006/main" xmlns:r="http://schemas.openxmlformats.org/officeDocument/2006/relationships">
+  <p:cSld>
+    <p:bg>
+      <p:bgPr>
+        <a:solidFill>
+          <a:srgbClr val="FAF9F7"/>
+        </a:solidFill>
+        <a:effectLst/>
+      </p:bgPr>
+    </p:bg>
+    <p:spTree>
+      <p:nvGrpSpPr>
+        <p:cNvPr id="1" name=""/>
+        <p:cNvGrpSpPr/>
+        <p:nvPr/>
+      </p:nvGrpSpPr>
+      <p:grpSpPr/>
+      <p:sp>
+        <p:nvSpPr>
+          <p:cNvPr id="2" name="TextBox 1"/>
+          <p:cNvSpPr txBox="1"/>
+          <p:nvPr/>
+        </p:nvSpPr>
+        <p:spPr>
+          <a:xfrm>
+            <a:off x="731520" y="731520"/>
+            <a:ext cx="10728655" cy="5394960"/>
+          </a:xfrm>
+          <a:prstGeom prst="rect">
+            <a:avLst/>
+          </a:prstGeom>
+          <a:noFill/>
+        </p:spPr>
+        <p:txBody>
+          <a:bodyPr wrap="square" anchor="ctr"/>
+          <a:lstStyle/>
+          <a:p>
+            <a:pPr algn="ctr"/>
+            <a:r>
+              <a:rPr sz="3600" b="1" i="0">
+                <a:solidFill>
+                  <a:srgbClr val="1A1A1A"/>
+                </a:solidFill>
+              </a:rPr>
+              <a:t>Quando Israel saiu do Egito, a casa de Jacó era um povo bárbaro, Judá tornou-se o seu santuário, Israel seu domínio.</a:t>
+            </a:r>
+          </a:p>
+        </p:txBody>
+      </p:sp>
+    </p:spTree>
+  </p:cSld>
+  <p:clrMapOvr>
+    <a:masterClrMapping/>
+  </p:clrMapOvr>
+</p:sld>
+</file>
+
+<file path=ppt/slides/slide68.xml><?xml version="1.0" encoding="utf-8"?>
+<p:sld xmlns:a="http://schemas.openxmlformats.org/drawingml/2006/main" xmlns:p="http://schemas.openxmlformats.org/presentationml/2006/main" xmlns:r="http://schemas.openxmlformats.org/officeDocument/2006/relationships">
+  <p:cSld>
+    <p:bg>
+      <p:bgPr>
+        <a:solidFill>
+          <a:srgbClr val="FAF9F7"/>
+        </a:solidFill>
+        <a:effectLst/>
+      </p:bgPr>
+    </p:bg>
+    <p:spTree>
+      <p:nvGrpSpPr>
+        <p:cNvPr id="1" name=""/>
+        <p:cNvGrpSpPr/>
+        <p:nvPr/>
+      </p:nvGrpSpPr>
+      <p:grpSpPr/>
+      <p:sp>
+        <p:nvSpPr>
+          <p:cNvPr id="2" name="TextBox 1"/>
+          <p:cNvSpPr txBox="1"/>
+          <p:nvPr/>
+        </p:nvSpPr>
+        <p:spPr>
+          <a:xfrm>
+            <a:off x="731520" y="731520"/>
+            <a:ext cx="10728655" cy="5394960"/>
+          </a:xfrm>
+          <a:prstGeom prst="rect">
+            <a:avLst/>
+          </a:prstGeom>
+          <a:noFill/>
+        </p:spPr>
+        <p:txBody>
+          <a:bodyPr wrap="square" anchor="ctr"/>
+          <a:lstStyle/>
+          <a:p>
+            <a:pPr algn="ctr"/>
+            <a:r>
+              <a:rPr sz="3200" b="0" i="0">
+                <a:solidFill>
+                  <a:srgbClr val="444444"/>
+                </a:solidFill>
+              </a:rPr>
+              <a:t>O que tem, mar, para fugir? E tu, Jordão, por que voltas? Por que vós, montes, saltam como um cordeiro no rebanho?</a:t>
+            </a:r>
+          </a:p>
+        </p:txBody>
+      </p:sp>
+    </p:spTree>
+  </p:cSld>
+  <p:clrMapOvr>
+    <a:masterClrMapping/>
+  </p:clrMapOvr>
+</p:sld>
+</file>
+
+<file path=ppt/slides/slide69.xml><?xml version="1.0" encoding="utf-8"?>
+<p:sld xmlns:a="http://schemas.openxmlformats.org/drawingml/2006/main" xmlns:p="http://schemas.openxmlformats.org/presentationml/2006/main" xmlns:r="http://schemas.openxmlformats.org/officeDocument/2006/relationships">
+  <p:cSld>
+    <p:bg>
+      <p:bgPr>
+        <a:solidFill>
+          <a:srgbClr val="FAF9F7"/>
+        </a:solidFill>
+        <a:effectLst/>
+      </p:bgPr>
+    </p:bg>
+    <p:spTree>
+      <p:nvGrpSpPr>
+        <p:cNvPr id="1" name=""/>
+        <p:cNvGrpSpPr/>
+        <p:nvPr/>
+      </p:nvGrpSpPr>
+      <p:grpSpPr/>
+      <p:sp>
+        <p:nvSpPr>
+          <p:cNvPr id="2" name="TextBox 1"/>
+          <p:cNvSpPr txBox="1"/>
+          <p:nvPr/>
+        </p:nvSpPr>
+        <p:spPr>
+          <a:xfrm>
+            <a:off x="731520" y="731520"/>
+            <a:ext cx="10728655" cy="5394960"/>
+          </a:xfrm>
+          <a:prstGeom prst="rect">
+            <a:avLst/>
+          </a:prstGeom>
+          <a:noFill/>
+        </p:spPr>
+        <p:txBody>
+          <a:bodyPr wrap="square" anchor="ctr"/>
+          <a:lstStyle/>
+          <a:p>
+            <a:pPr algn="ctr"/>
+            <a:r>
+              <a:rPr sz="3600" b="1" i="0">
+                <a:solidFill>
+                  <a:srgbClr val="1A1A1A"/>
+                </a:solidFill>
+              </a:rPr>
+              <a:t>Quando Israel saiu do Egito, a casa de Jacó era um povo bárbaro, Judá tornou-se o seu santuário, Israel seu domínio.</a:t>
             </a:r>
           </a:p>
         </p:txBody>
@@ -6006,7 +6749,123 @@
                   <a:srgbClr val="444444"/>
                 </a:solidFill>
               </a:rPr>
-              <a:t>Criai em mim um coração que seja puro, dai-me de novo um espírito firme. Meu sacrifício é minha alma penitente, não desprezeis um coração arrependido.</a:t>
+              <a:t>2. Eu reconheço toda a minha iniquidade, o meu pecado está sempre à minha frente. Foi contra vós somente que eu pequei e pratiquei o que é mau aos vossos olhos.</a:t>
+            </a:r>
+          </a:p>
+        </p:txBody>
+      </p:sp>
+    </p:spTree>
+  </p:cSld>
+  <p:clrMapOvr>
+    <a:masterClrMapping/>
+  </p:clrMapOvr>
+</p:sld>
+</file>
+
+<file path=ppt/slides/slide70.xml><?xml version="1.0" encoding="utf-8"?>
+<p:sld xmlns:a="http://schemas.openxmlformats.org/drawingml/2006/main" xmlns:p="http://schemas.openxmlformats.org/presentationml/2006/main" xmlns:r="http://schemas.openxmlformats.org/officeDocument/2006/relationships">
+  <p:cSld>
+    <p:bg>
+      <p:bgPr>
+        <a:solidFill>
+          <a:srgbClr val="FAF9F7"/>
+        </a:solidFill>
+        <a:effectLst/>
+      </p:bgPr>
+    </p:bg>
+    <p:spTree>
+      <p:nvGrpSpPr>
+        <p:cNvPr id="1" name=""/>
+        <p:cNvGrpSpPr/>
+        <p:nvPr/>
+      </p:nvGrpSpPr>
+      <p:grpSpPr/>
+      <p:sp>
+        <p:nvSpPr>
+          <p:cNvPr id="2" name="TextBox 1"/>
+          <p:cNvSpPr txBox="1"/>
+          <p:nvPr/>
+        </p:nvSpPr>
+        <p:spPr>
+          <a:xfrm>
+            <a:off x="731520" y="731520"/>
+            <a:ext cx="10728655" cy="5394960"/>
+          </a:xfrm>
+          <a:prstGeom prst="rect">
+            <a:avLst/>
+          </a:prstGeom>
+          <a:noFill/>
+        </p:spPr>
+        <p:txBody>
+          <a:bodyPr wrap="square" anchor="ctr"/>
+          <a:lstStyle/>
+          <a:p>
+            <a:pPr algn="ctr"/>
+            <a:r>
+              <a:rPr sz="3200" b="0" i="0">
+                <a:solidFill>
+                  <a:srgbClr val="444444"/>
+                </a:solidFill>
+              </a:rPr>
+              <a:t>Trema, ó terra, diante do Senhor, diante do Deus de Jacó, que muda o abismo em lago, a rocha em fonte de água.</a:t>
+            </a:r>
+          </a:p>
+        </p:txBody>
+      </p:sp>
+    </p:spTree>
+  </p:cSld>
+  <p:clrMapOvr>
+    <a:masterClrMapping/>
+  </p:clrMapOvr>
+</p:sld>
+</file>
+
+<file path=ppt/slides/slide71.xml><?xml version="1.0" encoding="utf-8"?>
+<p:sld xmlns:a="http://schemas.openxmlformats.org/drawingml/2006/main" xmlns:p="http://schemas.openxmlformats.org/presentationml/2006/main" xmlns:r="http://schemas.openxmlformats.org/officeDocument/2006/relationships">
+  <p:cSld>
+    <p:bg>
+      <p:bgPr>
+        <a:solidFill>
+          <a:srgbClr val="FAF9F7"/>
+        </a:solidFill>
+        <a:effectLst/>
+      </p:bgPr>
+    </p:bg>
+    <p:spTree>
+      <p:nvGrpSpPr>
+        <p:cNvPr id="1" name=""/>
+        <p:cNvGrpSpPr/>
+        <p:nvPr/>
+      </p:nvGrpSpPr>
+      <p:grpSpPr/>
+      <p:sp>
+        <p:nvSpPr>
+          <p:cNvPr id="2" name="TextBox 1"/>
+          <p:cNvSpPr txBox="1"/>
+          <p:nvPr/>
+        </p:nvSpPr>
+        <p:spPr>
+          <a:xfrm>
+            <a:off x="731520" y="731520"/>
+            <a:ext cx="10728655" cy="5394960"/>
+          </a:xfrm>
+          <a:prstGeom prst="rect">
+            <a:avLst/>
+          </a:prstGeom>
+          <a:noFill/>
+        </p:spPr>
+        <p:txBody>
+          <a:bodyPr wrap="square" anchor="ctr"/>
+          <a:lstStyle/>
+          <a:p>
+            <a:pPr algn="ctr"/>
+            <a:r>
+              <a:rPr sz="3600" b="1" i="0">
+                <a:solidFill>
+                  <a:srgbClr val="1A1A1A"/>
+                </a:solidFill>
+              </a:rPr>
+              <a:t>Quando Israel saiu do Egito, a casa de Jacó era um povo bárbaro, Judá tornou-se o seu santuário, Israel seu domínio.</a:t>
             </a:r>
           </a:p>
         </p:txBody>
@@ -6025,7 +6884,7 @@
     <p:bg>
       <p:bgPr>
         <a:solidFill>
-          <a:srgbClr val="000000"/>
+          <a:srgbClr val="FAF9F7"/>
         </a:solidFill>
         <a:effectLst/>
       </p:bgPr>
@@ -6037,6 +6896,38 @@
         <p:nvPr/>
       </p:nvGrpSpPr>
       <p:grpSpPr/>
+      <p:sp>
+        <p:nvSpPr>
+          <p:cNvPr id="2" name="TextBox 1"/>
+          <p:cNvSpPr txBox="1"/>
+          <p:nvPr/>
+        </p:nvSpPr>
+        <p:spPr>
+          <a:xfrm>
+            <a:off x="731520" y="731520"/>
+            <a:ext cx="10728655" cy="5394960"/>
+          </a:xfrm>
+          <a:prstGeom prst="rect">
+            <a:avLst/>
+          </a:prstGeom>
+          <a:noFill/>
+        </p:spPr>
+        <p:txBody>
+          <a:bodyPr wrap="square" anchor="ctr"/>
+          <a:lstStyle/>
+          <a:p>
+            <a:pPr algn="ctr"/>
+            <a:r>
+              <a:rPr sz="3600" b="1" i="0">
+                <a:solidFill>
+                  <a:srgbClr val="1A1A1A"/>
+                </a:solidFill>
+              </a:rPr>
+              <a:t>Miserere mei, Domine. Miserere mei, Domine.</a:t>
+            </a:r>
+          </a:p>
+        </p:txBody>
+      </p:sp>
     </p:spTree>
   </p:cSld>
   <p:clrMapOvr>
@@ -6071,8 +6962,8 @@
         </p:nvSpPr>
         <p:spPr>
           <a:xfrm>
-            <a:off x="731520" y="2057400"/>
-            <a:ext cx="10728655" cy="2400300"/>
+            <a:off x="731520" y="731520"/>
+            <a:ext cx="10728655" cy="5394960"/>
           </a:xfrm>
           <a:prstGeom prst="rect">
             <a:avLst/>
@@ -6085,12 +6976,12 @@
           <a:p>
             <a:pPr algn="ctr"/>
             <a:r>
-              <a:rPr sz="5200" b="1">
-                <a:solidFill>
-                  <a:srgbClr val="1A1A1A"/>
+              <a:rPr sz="3200" b="0" i="0">
+                <a:solidFill>
+                  <a:srgbClr val="444444"/>
                 </a:solidFill>
               </a:rPr>
-              <a:t>Aleluia</a:t>
+              <a:t>3. Criai em mim um coração que seja puro, dai-me de novo um espírito firme. Meu sacrifício é minha alma penitente, não desprezeis um coração arrependido.</a:t>
             </a:r>
           </a:p>
         </p:txBody>

</xml_diff>